<commit_message>
docs(cto-deck): drop the cost panel, sharpen the bottom of page 2
"What a run costs" was the weakest thing on a page about containment —
a budget line among controls — and "It works inside our own network"
described plumbing rather than making a point.

* cost → "Every action is written down": each run keeps a readable
  record of every step, and 20 actions that reach outside stop and ask a
  person. That is the question an auditor asks, and the page had no
  answer on it.
* the network panel → "Our code never leaves the building": prompts and
  code go only to the model we point at, and with that model on our own
  hardware it runs with the network off.
* the certificate line moves into "Our keys and our certificates", which
  is where someone looks for it.

Rendered on nuc and read back as an image.

Co-Authored-By: Claude Opus 5 (1M context) <noreply@anthropic.com>
Claude-Session: https://claude.ai/code/session_01NN6hF2RtVd76MdfdTHNdx5
</commit_message>
<xml_diff>
--- a/docs/AIForgeCrew-CTO-Summary.pptx
+++ b/docs/AIForgeCrew-CTO-Summary.pptx
@@ -9281,7 +9281,7 @@
                 </a:solidFill>
                 <a:latin typeface="Segoe UI"/>
               </a:rPr>
-              <a:t>What a run costs</a:t>
+              <a:t>Every action is written down</a:t>
             </a:r>
           </a:p>
         </p:txBody>
@@ -9384,7 +9384,7 @@
                 </a:solidFill>
                 <a:latin typeface="Segoe UI"/>
               </a:rPr>
-              <a:t>a cap on how often each agent may call the model</a:t>
+              <a:t>each run keeps a readable record of every step it took</a:t>
             </a:r>
           </a:p>
         </p:txBody>
@@ -9441,7 +9441,7 @@
                 </a:solidFill>
                 <a:latin typeface="Segoe UI"/>
               </a:rPr>
-              <a:t>our local model first; a paid one only after a real failure</a:t>
+              <a:t>20 actions that reach outside stop and ask a person</a:t>
             </a:r>
           </a:p>
         </p:txBody>
@@ -9463,11 +9463,11 @@
             </a:avLst>
           </a:prstGeom>
           <a:solidFill>
-            <a:srgbClr val="DCEEE7"/>
+            <a:srgbClr val="DCE7F2"/>
           </a:solidFill>
           <a:ln w="12700">
             <a:solidFill>
-              <a:srgbClr val="1E6B52"/>
+              <a:srgbClr val="1F4E79"/>
             </a:solidFill>
           </a:ln>
           <a:effectLst/>
@@ -9494,11 +9494,11 @@
             <a:r>
               <a:rPr sz="1150" b="1">
                 <a:solidFill>
-                  <a:srgbClr val="1E6B52"/>
-                </a:solidFill>
-                <a:latin typeface="Segoe UI"/>
-              </a:rPr>
-              <a:t>It works inside our own network</a:t>
+                  <a:srgbClr val="1F4E79"/>
+                </a:solidFill>
+                <a:latin typeface="Segoe UI"/>
+              </a:rPr>
+              <a:t>Our code never leaves the building</a:t>
             </a:r>
           </a:p>
         </p:txBody>
@@ -9522,7 +9522,7 @@
           </a:solidFill>
           <a:ln w="12700">
             <a:solidFill>
-              <a:srgbClr val="1E6B52"/>
+              <a:srgbClr val="1F4E79"/>
             </a:solidFill>
           </a:ln>
           <a:effectLst/>
@@ -9570,7 +9570,7 @@
           </a:solidFill>
           <a:ln w="12700">
             <a:solidFill>
-              <a:srgbClr val="1E6B52"/>
+              <a:srgbClr val="1F4E79"/>
             </a:solidFill>
           </a:ln>
           <a:effectLst/>
@@ -9597,11 +9597,11 @@
             <a:r>
               <a:rPr sz="850" b="0">
                 <a:solidFill>
-                  <a:srgbClr val="1E6B52"/>
-                </a:solidFill>
-                <a:latin typeface="Segoe UI"/>
-              </a:rPr>
-              <a:t>paste our own certificate authority into Settings — no restart</a:t>
+                  <a:srgbClr val="1F4E79"/>
+                </a:solidFill>
+                <a:latin typeface="Segoe UI"/>
+              </a:rPr>
+              <a:t>prompts and code go only to the model we point it at</a:t>
             </a:r>
           </a:p>
         </p:txBody>
@@ -9627,7 +9627,7 @@
           </a:solidFill>
           <a:ln w="12700">
             <a:solidFill>
-              <a:srgbClr val="1E6B52"/>
+              <a:srgbClr val="1F4E79"/>
             </a:solidFill>
           </a:ln>
           <a:effectLst/>
@@ -9654,11 +9654,11 @@
             <a:r>
               <a:rPr sz="850" b="0">
                 <a:solidFill>
-                  <a:srgbClr val="1E6B52"/>
-                </a:solidFill>
-                <a:latin typeface="Segoe UI"/>
-              </a:rPr>
-              <a:t>one setting covers the model, Jira, GitLab, git and curl</a:t>
+                  <a:srgbClr val="1F4E79"/>
+                </a:solidFill>
+                <a:latin typeface="Segoe UI"/>
+              </a:rPr>
+              <a:t>with that model on our own hardware, it runs with the network off</a:t>
             </a:r>
           </a:p>
         </p:txBody>
@@ -9715,7 +9715,7 @@
                 </a:solidFill>
                 <a:latin typeface="Segoe UI"/>
               </a:rPr>
-              <a:t>Keys and tokens</a:t>
+              <a:t>Our keys and our certificates</a:t>
             </a:r>
           </a:p>
         </p:txBody>
@@ -9818,7 +9818,7 @@
                 </a:solidFill>
                 <a:latin typeface="Segoe UI"/>
               </a:rPr>
-              <a:t>all of them in one locked folder, readable only by the service</a:t>
+              <a:t>keys sit in one locked folder and are never shown back</a:t>
             </a:r>
           </a:p>
         </p:txBody>
@@ -9875,7 +9875,7 @@
                 </a:solidFill>
                 <a:latin typeface="Segoe UI"/>
               </a:rPr>
-              <a:t>permissions are repaired every time it starts</a:t>
+              <a:t>our own certificate authority is added in Settings, no restart</a:t>
             </a:r>
           </a:p>
         </p:txBody>

</xml_diff>

<commit_message>
docs(cto-deck): page 3 says what the open-source agents do not do
"What it asks of us" was operations trivia on a page about what the
company keeps. It becomes the comparison instead, stated as three things
we have that a terminal agent does not:

* OpenCode, Aider and Cline stop at one machine — ours shares what it
  learns, which is the whole argument of the diagram above it;
* one chat loop there; nineteen agents here, carrying a ticket to a
  merge request;
* the enterprise parts they leave out — one gate on the way out, our own
  certificate authority, and approvals before anything reaches outside.

Named only the projects the claim is safe for: each of those is a
single-developer terminal or IDE agent with no shared team memory. The
running-it details move to the speaker notes.

Rendered on nuc and read back as an image.

Co-Authored-By: Claude Opus 5 (1M context) <noreply@anthropic.com>
Claude-Session: https://claude.ai/code/session_01NN6hF2RtVd76MdfdTHNdx5
</commit_message>
<xml_diff>
--- a/docs/AIForgeCrew-CTO-Summary.pptx
+++ b/docs/AIForgeCrew-CTO-Summary.pptx
@@ -11896,11 +11896,11 @@
             </a:avLst>
           </a:prstGeom>
           <a:solidFill>
-            <a:srgbClr val="ECECEC"/>
+            <a:srgbClr val="EAE1F0"/>
           </a:solidFill>
           <a:ln w="12700">
             <a:solidFill>
-              <a:srgbClr val="3A3A3A"/>
+              <a:srgbClr val="5B3A6E"/>
             </a:solidFill>
           </a:ln>
           <a:effectLst/>
@@ -11927,11 +11927,11 @@
             <a:r>
               <a:rPr sz="1150" b="1">
                 <a:solidFill>
-                  <a:srgbClr val="3A3A3A"/>
-                </a:solidFill>
-                <a:latin typeface="Segoe UI"/>
-              </a:rPr>
-              <a:t>What it asks of us</a:t>
+                  <a:srgbClr val="5B3A6E"/>
+                </a:solidFill>
+                <a:latin typeface="Segoe UI"/>
+              </a:rPr>
+              <a:t>What the open-source agents do not do</a:t>
             </a:r>
           </a:p>
         </p:txBody>
@@ -11955,7 +11955,7 @@
           </a:solidFill>
           <a:ln w="12700">
             <a:solidFill>
-              <a:srgbClr val="3A3A3A"/>
+              <a:srgbClr val="5B3A6E"/>
             </a:solidFill>
           </a:ln>
           <a:effectLst/>
@@ -12003,7 +12003,7 @@
           </a:solidFill>
           <a:ln w="12700">
             <a:solidFill>
-              <a:srgbClr val="3A3A3A"/>
+              <a:srgbClr val="5B3A6E"/>
             </a:solidFill>
           </a:ln>
           <a:effectLst/>
@@ -12030,11 +12030,11 @@
             <a:r>
               <a:rPr sz="850" b="0">
                 <a:solidFill>
-                  <a:srgbClr val="3A3A3A"/>
-                </a:solidFill>
-                <a:latin typeface="Segoe UI"/>
-              </a:rPr>
-              <a:t>one machine with a model on it — a desktop, a NUC or a server</a:t>
+                  <a:srgbClr val="5B3A6E"/>
+                </a:solidFill>
+                <a:latin typeface="Segoe UI"/>
+              </a:rPr>
+              <a:t>OpenCode, Aider and Cline stop at one machine — ours shares what it learns</a:t>
             </a:r>
           </a:p>
         </p:txBody>
@@ -12060,7 +12060,7 @@
           </a:solidFill>
           <a:ln w="12700">
             <a:solidFill>
-              <a:srgbClr val="3A3A3A"/>
+              <a:srgbClr val="5B3A6E"/>
             </a:solidFill>
           </a:ln>
           <a:effectLst/>
@@ -12087,11 +12087,11 @@
             <a:r>
               <a:rPr sz="850" b="0">
                 <a:solidFill>
-                  <a:srgbClr val="3A3A3A"/>
-                </a:solidFill>
-                <a:latin typeface="Segoe UI"/>
-              </a:rPr>
-              <a:t>one folder to back up; copy it and the machine has moved</a:t>
+                  <a:srgbClr val="5B3A6E"/>
+                </a:solidFill>
+                <a:latin typeface="Segoe UI"/>
+              </a:rPr>
+              <a:t>one chat loop there; 19 agents here, carrying a ticket to a merge request</a:t>
             </a:r>
           </a:p>
         </p:txBody>
@@ -12117,7 +12117,7 @@
           </a:solidFill>
           <a:ln w="12700">
             <a:solidFill>
-              <a:srgbClr val="3A3A3A"/>
+              <a:srgbClr val="5B3A6E"/>
             </a:solidFill>
           </a:ln>
           <a:effectLst/>
@@ -12144,11 +12144,11 @@
             <a:r>
               <a:rPr sz="850" b="0">
                 <a:solidFill>
-                  <a:srgbClr val="3A3A3A"/>
-                </a:solidFill>
-                <a:latin typeface="Segoe UI"/>
-              </a:rPr>
-              <a:t>upgrades pull and restart; the data migrates itself</a:t>
+                  <a:srgbClr val="5B3A6E"/>
+                </a:solidFill>
+                <a:latin typeface="Segoe UI"/>
+              </a:rPr>
+              <a:t>the enterprise parts they leave out: one gate out, our own CA, approvals</a:t>
             </a:r>
           </a:p>
         </p:txBody>

</xml_diff>

<commit_message>
fix(cto-deck): no gradients — the reviewer could not open the file
Reported twice: the deck will not open on a Mac. The package itself
checks out — archive intact, no float EMU coordinates, no duplicate
shape ids, correct spPr child order, valid gradient stops — and it
renders fine through LibreOffice, so nothing here is a proven cause.

What IS known: every deck before this one opened, and this one is the
first to carry <a:gradFill>. So the gradients go. The hero band gets its
depth from two stacked solid blocks instead, which every renderer agrees
on, and the hub and core discs become flat fills.

A page nobody can open is worth less than a page with a flat header, and
the visual difference at reading distance is close to nothing.

Rendered on nuc and read back as an image: the band still reads as a
band and no other page changed.

Co-Authored-By: Claude Opus 5 (1M context) <noreply@anthropic.com>
Claude-Session: https://claude.ai/code/session_01NN6hF2RtVd76MdfdTHNdx5
</commit_message>
<xml_diff>
--- a/docs/AIForgeCrew-CTO-Summary.pptx
+++ b/docs/AIForgeCrew-CTO-Summary.pptx
@@ -4100,17 +4100,9 @@
           <a:prstGeom prst="rect">
             <a:avLst/>
           </a:prstGeom>
-          <a:gradFill rotWithShape="1">
-            <a:gsLst>
-              <a:gs pos="0">
-                <a:srgbClr val="0B1B2B"/>
-              </a:gs>
-              <a:gs pos="100000">
-                <a:srgbClr val="183B5C"/>
-              </a:gs>
-            </a:gsLst>
-            <a:lin scaled="0" ang="0"/>
-          </a:gradFill>
+          <a:solidFill>
+            <a:srgbClr val="0B1B2B"/>
+          </a:solidFill>
           <a:ln>
             <a:noFill/>
           </a:ln>
@@ -4141,6 +4133,94 @@
       <p:sp>
         <p:nvSpPr>
           <p:cNvPr id="3" name="Rectangle 2"/>
+          <p:cNvSpPr/>
+          <p:nvPr/>
+        </p:nvSpPr>
+        <p:spPr>
+          <a:xfrm>
+            <a:off x="7498079" y="0"/>
+            <a:ext cx="4693616" cy="1481328"/>
+          </a:xfrm>
+          <a:prstGeom prst="rect">
+            <a:avLst/>
+          </a:prstGeom>
+          <a:solidFill>
+            <a:srgbClr val="183B5C"/>
+          </a:solidFill>
+          <a:ln>
+            <a:noFill/>
+          </a:ln>
+          <a:effectLst/>
+        </p:spPr>
+        <p:style>
+          <a:lnRef idx="1">
+            <a:schemeClr val="accent1"/>
+          </a:lnRef>
+          <a:fillRef idx="3">
+            <a:schemeClr val="accent1"/>
+          </a:fillRef>
+          <a:effectRef idx="2">
+            <a:schemeClr val="accent1"/>
+          </a:effectRef>
+          <a:fontRef idx="minor">
+            <a:schemeClr val="lt1"/>
+          </a:fontRef>
+        </p:style>
+        <p:txBody>
+          <a:bodyPr rtlCol="0" anchor="ctr" wrap="square"/>
+          <a:lstStyle/>
+          <a:p>
+            <a:pPr algn="ctr"/>
+          </a:p>
+        </p:txBody>
+      </p:sp>
+      <p:sp>
+        <p:nvSpPr>
+          <p:cNvPr id="4" name="Rectangle 3"/>
+          <p:cNvSpPr/>
+          <p:nvPr/>
+        </p:nvSpPr>
+        <p:spPr>
+          <a:xfrm>
+            <a:off x="7040880" y="0"/>
+            <a:ext cx="457200" cy="1481328"/>
+          </a:xfrm>
+          <a:prstGeom prst="rect">
+            <a:avLst/>
+          </a:prstGeom>
+          <a:solidFill>
+            <a:srgbClr val="112B44"/>
+          </a:solidFill>
+          <a:ln>
+            <a:noFill/>
+          </a:ln>
+          <a:effectLst/>
+        </p:spPr>
+        <p:style>
+          <a:lnRef idx="1">
+            <a:schemeClr val="accent1"/>
+          </a:lnRef>
+          <a:fillRef idx="3">
+            <a:schemeClr val="accent1"/>
+          </a:fillRef>
+          <a:effectRef idx="2">
+            <a:schemeClr val="accent1"/>
+          </a:effectRef>
+          <a:fontRef idx="minor">
+            <a:schemeClr val="lt1"/>
+          </a:fontRef>
+        </p:style>
+        <p:txBody>
+          <a:bodyPr rtlCol="0" anchor="ctr" wrap="square"/>
+          <a:lstStyle/>
+          <a:p>
+            <a:pPr algn="ctr"/>
+          </a:p>
+        </p:txBody>
+      </p:sp>
+      <p:sp>
+        <p:nvSpPr>
+          <p:cNvPr id="5" name="Rectangle 4"/>
           <p:cNvSpPr/>
           <p:nvPr/>
         </p:nvSpPr>
@@ -4184,7 +4264,7 @@
       </p:sp>
       <p:sp>
         <p:nvSpPr>
-          <p:cNvPr id="4" name="TextBox 3"/>
+          <p:cNvPr id="6" name="TextBox 5"/>
           <p:cNvSpPr txBox="1"/>
           <p:nvPr/>
         </p:nvSpPr>
@@ -4219,7 +4299,7 @@
       </p:sp>
       <p:sp>
         <p:nvSpPr>
-          <p:cNvPr id="5" name="TextBox 4"/>
+          <p:cNvPr id="7" name="TextBox 6"/>
           <p:cNvSpPr txBox="1"/>
           <p:nvPr/>
         </p:nvSpPr>
@@ -4254,7 +4334,7 @@
       </p:sp>
       <p:sp>
         <p:nvSpPr>
-          <p:cNvPr id="6" name="Oval 5"/>
+          <p:cNvPr id="8" name="Oval 7"/>
           <p:cNvSpPr/>
           <p:nvPr/>
         </p:nvSpPr>
@@ -4300,7 +4380,7 @@
       </p:sp>
       <p:sp>
         <p:nvSpPr>
-          <p:cNvPr id="7" name="TextBox 6"/>
+          <p:cNvPr id="9" name="TextBox 8"/>
           <p:cNvSpPr txBox="1"/>
           <p:nvPr/>
         </p:nvSpPr>
@@ -4335,7 +4415,7 @@
       </p:sp>
       <p:sp>
         <p:nvSpPr>
-          <p:cNvPr id="8" name="TextBox 7"/>
+          <p:cNvPr id="10" name="TextBox 9"/>
           <p:cNvSpPr txBox="1"/>
           <p:nvPr/>
         </p:nvSpPr>
@@ -4370,7 +4450,7 @@
       </p:sp>
       <p:sp>
         <p:nvSpPr>
-          <p:cNvPr id="9" name="Oval 8"/>
+          <p:cNvPr id="11" name="Oval 10"/>
           <p:cNvSpPr/>
           <p:nvPr/>
         </p:nvSpPr>
@@ -4416,7 +4496,7 @@
       </p:sp>
       <p:sp>
         <p:nvSpPr>
-          <p:cNvPr id="10" name="TextBox 9"/>
+          <p:cNvPr id="12" name="TextBox 11"/>
           <p:cNvSpPr txBox="1"/>
           <p:nvPr/>
         </p:nvSpPr>
@@ -4451,7 +4531,7 @@
       </p:sp>
       <p:sp>
         <p:nvSpPr>
-          <p:cNvPr id="11" name="TextBox 10"/>
+          <p:cNvPr id="13" name="TextBox 12"/>
           <p:cNvSpPr txBox="1"/>
           <p:nvPr/>
         </p:nvSpPr>
@@ -4486,7 +4566,7 @@
       </p:sp>
       <p:sp>
         <p:nvSpPr>
-          <p:cNvPr id="12" name="Oval 11"/>
+          <p:cNvPr id="14" name="Oval 13"/>
           <p:cNvSpPr/>
           <p:nvPr/>
         </p:nvSpPr>
@@ -4532,7 +4612,7 @@
       </p:sp>
       <p:sp>
         <p:nvSpPr>
-          <p:cNvPr id="13" name="TextBox 12"/>
+          <p:cNvPr id="15" name="TextBox 14"/>
           <p:cNvSpPr txBox="1"/>
           <p:nvPr/>
         </p:nvSpPr>
@@ -4567,7 +4647,7 @@
       </p:sp>
       <p:sp>
         <p:nvSpPr>
-          <p:cNvPr id="14" name="TextBox 13"/>
+          <p:cNvPr id="16" name="TextBox 15"/>
           <p:cNvSpPr txBox="1"/>
           <p:nvPr/>
         </p:nvSpPr>
@@ -4602,7 +4682,7 @@
       </p:sp>
       <p:sp>
         <p:nvSpPr>
-          <p:cNvPr id="15" name="Oval 14"/>
+          <p:cNvPr id="17" name="Oval 16"/>
           <p:cNvSpPr/>
           <p:nvPr/>
         </p:nvSpPr>
@@ -4648,7 +4728,7 @@
       </p:sp>
       <p:sp>
         <p:nvSpPr>
-          <p:cNvPr id="16" name="TextBox 15"/>
+          <p:cNvPr id="18" name="TextBox 17"/>
           <p:cNvSpPr txBox="1"/>
           <p:nvPr/>
         </p:nvSpPr>
@@ -4683,7 +4763,7 @@
       </p:sp>
       <p:sp>
         <p:nvSpPr>
-          <p:cNvPr id="17" name="TextBox 16"/>
+          <p:cNvPr id="19" name="TextBox 18"/>
           <p:cNvSpPr txBox="1"/>
           <p:nvPr/>
         </p:nvSpPr>
@@ -4718,7 +4798,7 @@
       </p:sp>
       <p:sp>
         <p:nvSpPr>
-          <p:cNvPr id="18" name="TextBox 17"/>
+          <p:cNvPr id="20" name="TextBox 19"/>
           <p:cNvSpPr txBox="1"/>
           <p:nvPr/>
         </p:nvSpPr>
@@ -4753,7 +4833,7 @@
       </p:sp>
       <p:sp>
         <p:nvSpPr>
-          <p:cNvPr id="19" name="Oval 18"/>
+          <p:cNvPr id="21" name="Oval 20"/>
           <p:cNvSpPr/>
           <p:nvPr/>
         </p:nvSpPr>
@@ -4797,7 +4877,7 @@
       </p:sp>
       <p:sp>
         <p:nvSpPr>
-          <p:cNvPr id="20" name="Oval 19"/>
+          <p:cNvPr id="22" name="Oval 21"/>
           <p:cNvSpPr/>
           <p:nvPr/>
         </p:nvSpPr>
@@ -4809,17 +4889,9 @@
           <a:prstGeom prst="ellipse">
             <a:avLst/>
           </a:prstGeom>
-          <a:gradFill rotWithShape="1">
-            <a:gsLst>
-              <a:gs pos="0">
-                <a:srgbClr val="183B5C"/>
-              </a:gs>
-              <a:gs pos="100000">
-                <a:srgbClr val="2B6CB0"/>
-              </a:gs>
-            </a:gsLst>
-            <a:lin scaled="0" ang="18900000"/>
-          </a:gradFill>
+          <a:solidFill>
+            <a:srgbClr val="183B5C"/>
+          </a:solidFill>
           <a:ln>
             <a:noFill/>
           </a:ln>
@@ -4882,7 +4954,7 @@
       </p:sp>
       <p:sp>
         <p:nvSpPr>
-          <p:cNvPr id="21" name="Rounded Rectangle 20"/>
+          <p:cNvPr id="23" name="Rounded Rectangle 22"/>
           <p:cNvSpPr/>
           <p:nvPr/>
         </p:nvSpPr>
@@ -4951,7 +5023,7 @@
       </p:sp>
       <p:cxnSp>
         <p:nvCxnSpPr>
-          <p:cNvPr id="22" name="Connector 21"/>
+          <p:cNvPr id="24" name="Connector 23"/>
           <p:cNvCxnSpPr/>
           <p:nvPr/>
         </p:nvCxnSpPr>
@@ -4987,7 +5059,7 @@
       </p:cxnSp>
       <p:sp>
         <p:nvSpPr>
-          <p:cNvPr id="23" name="Rounded Rectangle 22"/>
+          <p:cNvPr id="25" name="Rounded Rectangle 24"/>
           <p:cNvSpPr/>
           <p:nvPr/>
         </p:nvSpPr>
@@ -5056,7 +5128,7 @@
       </p:sp>
       <p:cxnSp>
         <p:nvCxnSpPr>
-          <p:cNvPr id="24" name="Connector 23"/>
+          <p:cNvPr id="26" name="Connector 25"/>
           <p:cNvCxnSpPr/>
           <p:nvPr/>
         </p:nvCxnSpPr>
@@ -5092,7 +5164,7 @@
       </p:cxnSp>
       <p:sp>
         <p:nvSpPr>
-          <p:cNvPr id="25" name="Rounded Rectangle 24"/>
+          <p:cNvPr id="27" name="Rounded Rectangle 26"/>
           <p:cNvSpPr/>
           <p:nvPr/>
         </p:nvSpPr>
@@ -5161,7 +5233,7 @@
       </p:sp>
       <p:cxnSp>
         <p:nvCxnSpPr>
-          <p:cNvPr id="26" name="Connector 25"/>
+          <p:cNvPr id="28" name="Connector 27"/>
           <p:cNvCxnSpPr/>
           <p:nvPr/>
         </p:nvCxnSpPr>
@@ -5197,7 +5269,7 @@
       </p:cxnSp>
       <p:sp>
         <p:nvSpPr>
-          <p:cNvPr id="27" name="Rounded Rectangle 26"/>
+          <p:cNvPr id="29" name="Rounded Rectangle 28"/>
           <p:cNvSpPr/>
           <p:nvPr/>
         </p:nvSpPr>
@@ -5266,7 +5338,7 @@
       </p:sp>
       <p:cxnSp>
         <p:nvCxnSpPr>
-          <p:cNvPr id="28" name="Connector 27"/>
+          <p:cNvPr id="30" name="Connector 29"/>
           <p:cNvCxnSpPr/>
           <p:nvPr/>
         </p:nvCxnSpPr>
@@ -5302,7 +5374,7 @@
       </p:cxnSp>
       <p:sp>
         <p:nvSpPr>
-          <p:cNvPr id="29" name="Rounded Rectangle 28"/>
+          <p:cNvPr id="31" name="Rounded Rectangle 30"/>
           <p:cNvSpPr/>
           <p:nvPr/>
         </p:nvSpPr>
@@ -5371,7 +5443,7 @@
       </p:sp>
       <p:cxnSp>
         <p:nvCxnSpPr>
-          <p:cNvPr id="30" name="Connector 29"/>
+          <p:cNvPr id="32" name="Connector 31"/>
           <p:cNvCxnSpPr/>
           <p:nvPr/>
         </p:nvCxnSpPr>
@@ -5407,7 +5479,7 @@
       </p:cxnSp>
       <p:sp>
         <p:nvSpPr>
-          <p:cNvPr id="31" name="Rounded Rectangle 30"/>
+          <p:cNvPr id="33" name="Rounded Rectangle 32"/>
           <p:cNvSpPr/>
           <p:nvPr/>
         </p:nvSpPr>
@@ -5476,7 +5548,7 @@
       </p:sp>
       <p:cxnSp>
         <p:nvCxnSpPr>
-          <p:cNvPr id="32" name="Connector 31"/>
+          <p:cNvPr id="34" name="Connector 33"/>
           <p:cNvCxnSpPr/>
           <p:nvPr/>
         </p:nvCxnSpPr>
@@ -5512,7 +5584,7 @@
       </p:cxnSp>
       <p:sp>
         <p:nvSpPr>
-          <p:cNvPr id="33" name="TextBox 32"/>
+          <p:cNvPr id="35" name="TextBox 34"/>
           <p:cNvSpPr txBox="1"/>
           <p:nvPr/>
         </p:nvSpPr>
@@ -5547,7 +5619,7 @@
       </p:sp>
       <p:sp>
         <p:nvSpPr>
-          <p:cNvPr id="34" name="TextBox 33"/>
+          <p:cNvPr id="36" name="TextBox 35"/>
           <p:cNvSpPr txBox="1"/>
           <p:nvPr/>
         </p:nvSpPr>
@@ -5582,7 +5654,7 @@
       </p:sp>
       <p:sp>
         <p:nvSpPr>
-          <p:cNvPr id="35" name="TextBox 34"/>
+          <p:cNvPr id="37" name="TextBox 36"/>
           <p:cNvSpPr txBox="1"/>
           <p:nvPr/>
         </p:nvSpPr>
@@ -5617,7 +5689,7 @@
       </p:sp>
       <p:sp>
         <p:nvSpPr>
-          <p:cNvPr id="36" name="Chevron 35"/>
+          <p:cNvPr id="38" name="Chevron 37"/>
           <p:cNvSpPr/>
           <p:nvPr/>
         </p:nvSpPr>
@@ -5674,7 +5746,7 @@
       </p:sp>
       <p:sp>
         <p:nvSpPr>
-          <p:cNvPr id="37" name="Chevron 36"/>
+          <p:cNvPr id="39" name="Chevron 38"/>
           <p:cNvSpPr/>
           <p:nvPr/>
         </p:nvSpPr>
@@ -5731,7 +5803,7 @@
       </p:sp>
       <p:sp>
         <p:nvSpPr>
-          <p:cNvPr id="38" name="Chevron 37"/>
+          <p:cNvPr id="40" name="Chevron 39"/>
           <p:cNvSpPr/>
           <p:nvPr/>
         </p:nvSpPr>
@@ -5788,7 +5860,7 @@
       </p:sp>
       <p:sp>
         <p:nvSpPr>
-          <p:cNvPr id="39" name="Chevron 38"/>
+          <p:cNvPr id="41" name="Chevron 40"/>
           <p:cNvSpPr/>
           <p:nvPr/>
         </p:nvSpPr>
@@ -5845,7 +5917,7 @@
       </p:sp>
       <p:sp>
         <p:nvSpPr>
-          <p:cNvPr id="40" name="Chevron 39"/>
+          <p:cNvPr id="42" name="Chevron 41"/>
           <p:cNvSpPr/>
           <p:nvPr/>
         </p:nvSpPr>
@@ -5902,7 +5974,7 @@
       </p:sp>
       <p:sp>
         <p:nvSpPr>
-          <p:cNvPr id="41" name="Chevron 40"/>
+          <p:cNvPr id="43" name="Chevron 42"/>
           <p:cNvSpPr/>
           <p:nvPr/>
         </p:nvSpPr>
@@ -5959,7 +6031,7 @@
       </p:sp>
       <p:sp>
         <p:nvSpPr>
-          <p:cNvPr id="42" name="TextBox 41"/>
+          <p:cNvPr id="44" name="TextBox 43"/>
           <p:cNvSpPr txBox="1"/>
           <p:nvPr/>
         </p:nvSpPr>
@@ -5994,7 +6066,7 @@
       </p:sp>
       <p:sp>
         <p:nvSpPr>
-          <p:cNvPr id="43" name="Rounded Rectangle 42"/>
+          <p:cNvPr id="45" name="Rounded Rectangle 44"/>
           <p:cNvSpPr/>
           <p:nvPr/>
         </p:nvSpPr>
@@ -6040,7 +6112,7 @@
       </p:sp>
       <p:sp>
         <p:nvSpPr>
-          <p:cNvPr id="44" name="Oval 43"/>
+          <p:cNvPr id="46" name="Oval 45"/>
           <p:cNvSpPr/>
           <p:nvPr/>
         </p:nvSpPr>
@@ -6084,7 +6156,7 @@
       </p:sp>
       <p:sp>
         <p:nvSpPr>
-          <p:cNvPr id="45" name="TextBox 44"/>
+          <p:cNvPr id="47" name="TextBox 46"/>
           <p:cNvSpPr txBox="1"/>
           <p:nvPr/>
         </p:nvSpPr>
@@ -6119,7 +6191,7 @@
       </p:sp>
       <p:sp>
         <p:nvSpPr>
-          <p:cNvPr id="46" name="TextBox 45"/>
+          <p:cNvPr id="48" name="TextBox 47"/>
           <p:cNvSpPr txBox="1"/>
           <p:nvPr/>
         </p:nvSpPr>
@@ -6163,7 +6235,7 @@
       </p:sp>
       <p:sp>
         <p:nvSpPr>
-          <p:cNvPr id="47" name="Oval 46"/>
+          <p:cNvPr id="49" name="Oval 48"/>
           <p:cNvSpPr/>
           <p:nvPr/>
         </p:nvSpPr>
@@ -6207,7 +6279,7 @@
       </p:sp>
       <p:sp>
         <p:nvSpPr>
-          <p:cNvPr id="48" name="TextBox 47"/>
+          <p:cNvPr id="50" name="TextBox 49"/>
           <p:cNvSpPr txBox="1"/>
           <p:nvPr/>
         </p:nvSpPr>
@@ -6242,7 +6314,7 @@
       </p:sp>
       <p:sp>
         <p:nvSpPr>
-          <p:cNvPr id="49" name="TextBox 48"/>
+          <p:cNvPr id="51" name="TextBox 50"/>
           <p:cNvSpPr txBox="1"/>
           <p:nvPr/>
         </p:nvSpPr>
@@ -6286,7 +6358,7 @@
       </p:sp>
       <p:sp>
         <p:nvSpPr>
-          <p:cNvPr id="50" name="TextBox 49"/>
+          <p:cNvPr id="52" name="TextBox 51"/>
           <p:cNvSpPr txBox="1"/>
           <p:nvPr/>
         </p:nvSpPr>
@@ -6321,7 +6393,7 @@
       </p:sp>
       <p:sp>
         <p:nvSpPr>
-          <p:cNvPr id="51" name="TextBox 50"/>
+          <p:cNvPr id="53" name="TextBox 52"/>
           <p:cNvSpPr txBox="1"/>
           <p:nvPr/>
         </p:nvSpPr>
@@ -6386,17 +6458,9 @@
           <a:prstGeom prst="rect">
             <a:avLst/>
           </a:prstGeom>
-          <a:gradFill rotWithShape="1">
-            <a:gsLst>
-              <a:gs pos="0">
-                <a:srgbClr val="0B1B2B"/>
-              </a:gs>
-              <a:gs pos="100000">
-                <a:srgbClr val="183B5C"/>
-              </a:gs>
-            </a:gsLst>
-            <a:lin scaled="0" ang="0"/>
-          </a:gradFill>
+          <a:solidFill>
+            <a:srgbClr val="0B1B2B"/>
+          </a:solidFill>
           <a:ln>
             <a:noFill/>
           </a:ln>
@@ -6427,6 +6491,94 @@
       <p:sp>
         <p:nvSpPr>
           <p:cNvPr id="3" name="Rectangle 2"/>
+          <p:cNvSpPr/>
+          <p:nvPr/>
+        </p:nvSpPr>
+        <p:spPr>
+          <a:xfrm>
+            <a:off x="7498079" y="0"/>
+            <a:ext cx="4693616" cy="1481328"/>
+          </a:xfrm>
+          <a:prstGeom prst="rect">
+            <a:avLst/>
+          </a:prstGeom>
+          <a:solidFill>
+            <a:srgbClr val="183B5C"/>
+          </a:solidFill>
+          <a:ln>
+            <a:noFill/>
+          </a:ln>
+          <a:effectLst/>
+        </p:spPr>
+        <p:style>
+          <a:lnRef idx="1">
+            <a:schemeClr val="accent1"/>
+          </a:lnRef>
+          <a:fillRef idx="3">
+            <a:schemeClr val="accent1"/>
+          </a:fillRef>
+          <a:effectRef idx="2">
+            <a:schemeClr val="accent1"/>
+          </a:effectRef>
+          <a:fontRef idx="minor">
+            <a:schemeClr val="lt1"/>
+          </a:fontRef>
+        </p:style>
+        <p:txBody>
+          <a:bodyPr rtlCol="0" anchor="ctr" wrap="square"/>
+          <a:lstStyle/>
+          <a:p>
+            <a:pPr algn="ctr"/>
+          </a:p>
+        </p:txBody>
+      </p:sp>
+      <p:sp>
+        <p:nvSpPr>
+          <p:cNvPr id="4" name="Rectangle 3"/>
+          <p:cNvSpPr/>
+          <p:nvPr/>
+        </p:nvSpPr>
+        <p:spPr>
+          <a:xfrm>
+            <a:off x="7040880" y="0"/>
+            <a:ext cx="457200" cy="1481328"/>
+          </a:xfrm>
+          <a:prstGeom prst="rect">
+            <a:avLst/>
+          </a:prstGeom>
+          <a:solidFill>
+            <a:srgbClr val="112B44"/>
+          </a:solidFill>
+          <a:ln>
+            <a:noFill/>
+          </a:ln>
+          <a:effectLst/>
+        </p:spPr>
+        <p:style>
+          <a:lnRef idx="1">
+            <a:schemeClr val="accent1"/>
+          </a:lnRef>
+          <a:fillRef idx="3">
+            <a:schemeClr val="accent1"/>
+          </a:fillRef>
+          <a:effectRef idx="2">
+            <a:schemeClr val="accent1"/>
+          </a:effectRef>
+          <a:fontRef idx="minor">
+            <a:schemeClr val="lt1"/>
+          </a:fontRef>
+        </p:style>
+        <p:txBody>
+          <a:bodyPr rtlCol="0" anchor="ctr" wrap="square"/>
+          <a:lstStyle/>
+          <a:p>
+            <a:pPr algn="ctr"/>
+          </a:p>
+        </p:txBody>
+      </p:sp>
+      <p:sp>
+        <p:nvSpPr>
+          <p:cNvPr id="5" name="Rectangle 4"/>
           <p:cNvSpPr/>
           <p:nvPr/>
         </p:nvSpPr>
@@ -6470,7 +6622,7 @@
       </p:sp>
       <p:sp>
         <p:nvSpPr>
-          <p:cNvPr id="4" name="TextBox 3"/>
+          <p:cNvPr id="6" name="TextBox 5"/>
           <p:cNvSpPr txBox="1"/>
           <p:nvPr/>
         </p:nvSpPr>
@@ -6505,7 +6657,7 @@
       </p:sp>
       <p:sp>
         <p:nvSpPr>
-          <p:cNvPr id="5" name="TextBox 4"/>
+          <p:cNvPr id="7" name="TextBox 6"/>
           <p:cNvSpPr txBox="1"/>
           <p:nvPr/>
         </p:nvSpPr>
@@ -6540,7 +6692,7 @@
       </p:sp>
       <p:sp>
         <p:nvSpPr>
-          <p:cNvPr id="6" name="Oval 5"/>
+          <p:cNvPr id="8" name="Oval 7"/>
           <p:cNvSpPr/>
           <p:nvPr/>
         </p:nvSpPr>
@@ -6586,7 +6738,7 @@
       </p:sp>
       <p:sp>
         <p:nvSpPr>
-          <p:cNvPr id="7" name="TextBox 6"/>
+          <p:cNvPr id="9" name="TextBox 8"/>
           <p:cNvSpPr txBox="1"/>
           <p:nvPr/>
         </p:nvSpPr>
@@ -6621,7 +6773,7 @@
       </p:sp>
       <p:sp>
         <p:nvSpPr>
-          <p:cNvPr id="8" name="TextBox 7"/>
+          <p:cNvPr id="10" name="TextBox 9"/>
           <p:cNvSpPr txBox="1"/>
           <p:nvPr/>
         </p:nvSpPr>
@@ -6656,7 +6808,7 @@
       </p:sp>
       <p:sp>
         <p:nvSpPr>
-          <p:cNvPr id="9" name="Oval 8"/>
+          <p:cNvPr id="11" name="Oval 10"/>
           <p:cNvSpPr/>
           <p:nvPr/>
         </p:nvSpPr>
@@ -6702,7 +6854,7 @@
       </p:sp>
       <p:sp>
         <p:nvSpPr>
-          <p:cNvPr id="10" name="TextBox 9"/>
+          <p:cNvPr id="12" name="TextBox 11"/>
           <p:cNvSpPr txBox="1"/>
           <p:nvPr/>
         </p:nvSpPr>
@@ -6737,7 +6889,7 @@
       </p:sp>
       <p:sp>
         <p:nvSpPr>
-          <p:cNvPr id="11" name="TextBox 10"/>
+          <p:cNvPr id="13" name="TextBox 12"/>
           <p:cNvSpPr txBox="1"/>
           <p:nvPr/>
         </p:nvSpPr>
@@ -6772,7 +6924,7 @@
       </p:sp>
       <p:sp>
         <p:nvSpPr>
-          <p:cNvPr id="12" name="Oval 11"/>
+          <p:cNvPr id="14" name="Oval 13"/>
           <p:cNvSpPr/>
           <p:nvPr/>
         </p:nvSpPr>
@@ -6818,7 +6970,7 @@
       </p:sp>
       <p:sp>
         <p:nvSpPr>
-          <p:cNvPr id="13" name="TextBox 12"/>
+          <p:cNvPr id="15" name="TextBox 14"/>
           <p:cNvSpPr txBox="1"/>
           <p:nvPr/>
         </p:nvSpPr>
@@ -6853,7 +7005,7 @@
       </p:sp>
       <p:sp>
         <p:nvSpPr>
-          <p:cNvPr id="14" name="TextBox 13"/>
+          <p:cNvPr id="16" name="TextBox 15"/>
           <p:cNvSpPr txBox="1"/>
           <p:nvPr/>
         </p:nvSpPr>
@@ -6888,7 +7040,7 @@
       </p:sp>
       <p:sp>
         <p:nvSpPr>
-          <p:cNvPr id="15" name="TextBox 14"/>
+          <p:cNvPr id="17" name="TextBox 16"/>
           <p:cNvSpPr txBox="1"/>
           <p:nvPr/>
         </p:nvSpPr>
@@ -6923,7 +7075,7 @@
       </p:sp>
       <p:sp>
         <p:nvSpPr>
-          <p:cNvPr id="16" name="Oval 15"/>
+          <p:cNvPr id="18" name="Oval 17"/>
           <p:cNvSpPr/>
           <p:nvPr/>
         </p:nvSpPr>
@@ -6969,7 +7121,7 @@
       </p:sp>
       <p:sp>
         <p:nvSpPr>
-          <p:cNvPr id="17" name="Oval 16"/>
+          <p:cNvPr id="19" name="Oval 18"/>
           <p:cNvSpPr/>
           <p:nvPr/>
         </p:nvSpPr>
@@ -7015,7 +7167,7 @@
       </p:sp>
       <p:sp>
         <p:nvSpPr>
-          <p:cNvPr id="18" name="Oval 17"/>
+          <p:cNvPr id="20" name="Oval 19"/>
           <p:cNvSpPr/>
           <p:nvPr/>
         </p:nvSpPr>
@@ -7061,7 +7213,7 @@
       </p:sp>
       <p:sp>
         <p:nvSpPr>
-          <p:cNvPr id="19" name="Oval 18"/>
+          <p:cNvPr id="21" name="Oval 20"/>
           <p:cNvSpPr/>
           <p:nvPr/>
         </p:nvSpPr>
@@ -7073,17 +7225,9 @@
           <a:prstGeom prst="ellipse">
             <a:avLst/>
           </a:prstGeom>
-          <a:gradFill rotWithShape="1">
-            <a:gsLst>
-              <a:gs pos="0">
-                <a:srgbClr val="183B5C"/>
-              </a:gs>
-              <a:gs pos="100000">
-                <a:srgbClr val="2C7A7B"/>
-              </a:gs>
-            </a:gsLst>
-            <a:lin scaled="0" ang="18900000"/>
-          </a:gradFill>
+          <a:solidFill>
+            <a:srgbClr val="183B5C"/>
+          </a:solidFill>
           <a:ln>
             <a:noFill/>
           </a:ln>
@@ -7134,7 +7278,7 @@
       </p:sp>
       <p:sp>
         <p:nvSpPr>
-          <p:cNvPr id="20" name="Rounded Rectangle 19"/>
+          <p:cNvPr id="22" name="Rounded Rectangle 21"/>
           <p:cNvSpPr/>
           <p:nvPr/>
         </p:nvSpPr>
@@ -7182,7 +7326,7 @@
       </p:sp>
       <p:sp>
         <p:nvSpPr>
-          <p:cNvPr id="21" name="TextBox 20"/>
+          <p:cNvPr id="23" name="TextBox 22"/>
           <p:cNvSpPr txBox="1"/>
           <p:nvPr/>
         </p:nvSpPr>
@@ -7217,7 +7361,7 @@
       </p:sp>
       <p:sp>
         <p:nvSpPr>
-          <p:cNvPr id="22" name="Rounded Rectangle 21"/>
+          <p:cNvPr id="24" name="Rounded Rectangle 23"/>
           <p:cNvSpPr/>
           <p:nvPr/>
         </p:nvSpPr>
@@ -7265,7 +7409,7 @@
       </p:sp>
       <p:sp>
         <p:nvSpPr>
-          <p:cNvPr id="23" name="TextBox 22"/>
+          <p:cNvPr id="25" name="TextBox 24"/>
           <p:cNvSpPr txBox="1"/>
           <p:nvPr/>
         </p:nvSpPr>
@@ -7300,7 +7444,7 @@
       </p:sp>
       <p:sp>
         <p:nvSpPr>
-          <p:cNvPr id="24" name="Rounded Rectangle 23"/>
+          <p:cNvPr id="26" name="Rounded Rectangle 25"/>
           <p:cNvSpPr/>
           <p:nvPr/>
         </p:nvSpPr>
@@ -7348,7 +7492,7 @@
       </p:sp>
       <p:sp>
         <p:nvSpPr>
-          <p:cNvPr id="25" name="TextBox 24"/>
+          <p:cNvPr id="27" name="TextBox 26"/>
           <p:cNvSpPr txBox="1"/>
           <p:nvPr/>
         </p:nvSpPr>
@@ -7383,7 +7527,7 @@
       </p:sp>
       <p:sp>
         <p:nvSpPr>
-          <p:cNvPr id="26" name="TextBox 25"/>
+          <p:cNvPr id="28" name="TextBox 27"/>
           <p:cNvSpPr txBox="1"/>
           <p:nvPr/>
         </p:nvSpPr>
@@ -7418,7 +7562,7 @@
       </p:sp>
       <p:sp>
         <p:nvSpPr>
-          <p:cNvPr id="27" name="TextBox 26"/>
+          <p:cNvPr id="29" name="TextBox 28"/>
           <p:cNvSpPr txBox="1"/>
           <p:nvPr/>
         </p:nvSpPr>
@@ -7453,7 +7597,7 @@
       </p:sp>
       <p:cxnSp>
         <p:nvCxnSpPr>
-          <p:cNvPr id="28" name="Connector 27"/>
+          <p:cNvPr id="30" name="Connector 29"/>
           <p:cNvCxnSpPr/>
           <p:nvPr/>
         </p:nvCxnSpPr>
@@ -7489,7 +7633,7 @@
       </p:cxnSp>
       <p:sp>
         <p:nvSpPr>
-          <p:cNvPr id="29" name="TextBox 28"/>
+          <p:cNvPr id="31" name="TextBox 30"/>
           <p:cNvSpPr txBox="1"/>
           <p:nvPr/>
         </p:nvSpPr>
@@ -7524,7 +7668,7 @@
       </p:sp>
       <p:sp>
         <p:nvSpPr>
-          <p:cNvPr id="30" name="TextBox 29"/>
+          <p:cNvPr id="32" name="TextBox 31"/>
           <p:cNvSpPr txBox="1"/>
           <p:nvPr/>
         </p:nvSpPr>
@@ -7559,7 +7703,7 @@
       </p:sp>
       <p:cxnSp>
         <p:nvCxnSpPr>
-          <p:cNvPr id="31" name="Connector 30"/>
+          <p:cNvPr id="33" name="Connector 32"/>
           <p:cNvCxnSpPr/>
           <p:nvPr/>
         </p:nvCxnSpPr>
@@ -7595,7 +7739,7 @@
       </p:cxnSp>
       <p:sp>
         <p:nvSpPr>
-          <p:cNvPr id="32" name="TextBox 31"/>
+          <p:cNvPr id="34" name="TextBox 33"/>
           <p:cNvSpPr txBox="1"/>
           <p:nvPr/>
         </p:nvSpPr>
@@ -7630,7 +7774,7 @@
       </p:sp>
       <p:sp>
         <p:nvSpPr>
-          <p:cNvPr id="33" name="TextBox 32"/>
+          <p:cNvPr id="35" name="TextBox 34"/>
           <p:cNvSpPr txBox="1"/>
           <p:nvPr/>
         </p:nvSpPr>
@@ -7665,7 +7809,7 @@
       </p:sp>
       <p:cxnSp>
         <p:nvCxnSpPr>
-          <p:cNvPr id="34" name="Connector 33"/>
+          <p:cNvPr id="36" name="Connector 35"/>
           <p:cNvCxnSpPr/>
           <p:nvPr/>
         </p:nvCxnSpPr>
@@ -7701,7 +7845,7 @@
       </p:cxnSp>
       <p:sp>
         <p:nvSpPr>
-          <p:cNvPr id="35" name="TextBox 34"/>
+          <p:cNvPr id="37" name="TextBox 36"/>
           <p:cNvSpPr txBox="1"/>
           <p:nvPr/>
         </p:nvSpPr>
@@ -7736,7 +7880,7 @@
       </p:sp>
       <p:sp>
         <p:nvSpPr>
-          <p:cNvPr id="36" name="Rounded Rectangle 35"/>
+          <p:cNvPr id="38" name="Rounded Rectangle 37"/>
           <p:cNvSpPr/>
           <p:nvPr/>
         </p:nvSpPr>
@@ -7782,7 +7926,7 @@
       </p:sp>
       <p:sp>
         <p:nvSpPr>
-          <p:cNvPr id="37" name="TextBox 36"/>
+          <p:cNvPr id="39" name="TextBox 38"/>
           <p:cNvSpPr txBox="1"/>
           <p:nvPr/>
         </p:nvSpPr>
@@ -7817,7 +7961,7 @@
       </p:sp>
       <p:sp>
         <p:nvSpPr>
-          <p:cNvPr id="38" name="TextBox 37"/>
+          <p:cNvPr id="40" name="TextBox 39"/>
           <p:cNvSpPr txBox="1"/>
           <p:nvPr/>
         </p:nvSpPr>
@@ -7852,7 +7996,7 @@
       </p:sp>
       <p:sp>
         <p:nvSpPr>
-          <p:cNvPr id="39" name="TextBox 38"/>
+          <p:cNvPr id="41" name="TextBox 40"/>
           <p:cNvSpPr txBox="1"/>
           <p:nvPr/>
         </p:nvSpPr>
@@ -7887,7 +8031,7 @@
       </p:sp>
       <p:sp>
         <p:nvSpPr>
-          <p:cNvPr id="40" name="TextBox 39"/>
+          <p:cNvPr id="42" name="TextBox 41"/>
           <p:cNvSpPr txBox="1"/>
           <p:nvPr/>
         </p:nvSpPr>
@@ -7922,7 +8066,7 @@
       </p:sp>
       <p:sp>
         <p:nvSpPr>
-          <p:cNvPr id="41" name="Rounded Rectangle 40"/>
+          <p:cNvPr id="43" name="Rounded Rectangle 42"/>
           <p:cNvSpPr/>
           <p:nvPr/>
         </p:nvSpPr>
@@ -7968,7 +8112,7 @@
       </p:sp>
       <p:sp>
         <p:nvSpPr>
-          <p:cNvPr id="42" name="TextBox 41"/>
+          <p:cNvPr id="44" name="TextBox 43"/>
           <p:cNvSpPr txBox="1"/>
           <p:nvPr/>
         </p:nvSpPr>
@@ -8003,7 +8147,7 @@
       </p:sp>
       <p:sp>
         <p:nvSpPr>
-          <p:cNvPr id="43" name="TextBox 42"/>
+          <p:cNvPr id="45" name="TextBox 44"/>
           <p:cNvSpPr txBox="1"/>
           <p:nvPr/>
         </p:nvSpPr>
@@ -8038,7 +8182,7 @@
       </p:sp>
       <p:sp>
         <p:nvSpPr>
-          <p:cNvPr id="44" name="TextBox 43"/>
+          <p:cNvPr id="46" name="TextBox 45"/>
           <p:cNvSpPr txBox="1"/>
           <p:nvPr/>
         </p:nvSpPr>
@@ -8073,7 +8217,7 @@
       </p:sp>
       <p:sp>
         <p:nvSpPr>
-          <p:cNvPr id="45" name="TextBox 44"/>
+          <p:cNvPr id="47" name="TextBox 46"/>
           <p:cNvSpPr txBox="1"/>
           <p:nvPr/>
         </p:nvSpPr>
@@ -8108,7 +8252,7 @@
       </p:sp>
       <p:sp>
         <p:nvSpPr>
-          <p:cNvPr id="46" name="TextBox 45"/>
+          <p:cNvPr id="48" name="TextBox 47"/>
           <p:cNvSpPr txBox="1"/>
           <p:nvPr/>
         </p:nvSpPr>
@@ -8143,7 +8287,7 @@
       </p:sp>
       <p:sp>
         <p:nvSpPr>
-          <p:cNvPr id="47" name="Rectangle 46"/>
+          <p:cNvPr id="49" name="Rectangle 48"/>
           <p:cNvSpPr/>
           <p:nvPr/>
         </p:nvSpPr>
@@ -8187,7 +8331,7 @@
       </p:sp>
       <p:sp>
         <p:nvSpPr>
-          <p:cNvPr id="48" name="Oval 47"/>
+          <p:cNvPr id="50" name="Oval 49"/>
           <p:cNvSpPr/>
           <p:nvPr/>
         </p:nvSpPr>
@@ -8231,7 +8375,7 @@
       </p:sp>
       <p:sp>
         <p:nvSpPr>
-          <p:cNvPr id="49" name="TextBox 48"/>
+          <p:cNvPr id="51" name="TextBox 50"/>
           <p:cNvSpPr txBox="1"/>
           <p:nvPr/>
         </p:nvSpPr>
@@ -8266,7 +8410,7 @@
       </p:sp>
       <p:sp>
         <p:nvSpPr>
-          <p:cNvPr id="50" name="TextBox 49"/>
+          <p:cNvPr id="52" name="TextBox 51"/>
           <p:cNvSpPr txBox="1"/>
           <p:nvPr/>
         </p:nvSpPr>
@@ -8310,7 +8454,7 @@
       </p:sp>
       <p:sp>
         <p:nvSpPr>
-          <p:cNvPr id="51" name="Oval 50"/>
+          <p:cNvPr id="53" name="Oval 52"/>
           <p:cNvSpPr/>
           <p:nvPr/>
         </p:nvSpPr>
@@ -8354,7 +8498,7 @@
       </p:sp>
       <p:sp>
         <p:nvSpPr>
-          <p:cNvPr id="52" name="TextBox 51"/>
+          <p:cNvPr id="54" name="TextBox 53"/>
           <p:cNvSpPr txBox="1"/>
           <p:nvPr/>
         </p:nvSpPr>
@@ -8389,7 +8533,7 @@
       </p:sp>
       <p:sp>
         <p:nvSpPr>
-          <p:cNvPr id="53" name="TextBox 52"/>
+          <p:cNvPr id="55" name="TextBox 54"/>
           <p:cNvSpPr txBox="1"/>
           <p:nvPr/>
         </p:nvSpPr>
@@ -8433,7 +8577,7 @@
       </p:sp>
       <p:sp>
         <p:nvSpPr>
-          <p:cNvPr id="54" name="Oval 53"/>
+          <p:cNvPr id="56" name="Oval 55"/>
           <p:cNvSpPr/>
           <p:nvPr/>
         </p:nvSpPr>
@@ -8477,7 +8621,7 @@
       </p:sp>
       <p:sp>
         <p:nvSpPr>
-          <p:cNvPr id="55" name="TextBox 54"/>
+          <p:cNvPr id="57" name="TextBox 56"/>
           <p:cNvSpPr txBox="1"/>
           <p:nvPr/>
         </p:nvSpPr>
@@ -8512,7 +8656,7 @@
       </p:sp>
       <p:sp>
         <p:nvSpPr>
-          <p:cNvPr id="56" name="TextBox 55"/>
+          <p:cNvPr id="58" name="TextBox 57"/>
           <p:cNvSpPr txBox="1"/>
           <p:nvPr/>
         </p:nvSpPr>
@@ -8556,7 +8700,7 @@
       </p:sp>
       <p:sp>
         <p:nvSpPr>
-          <p:cNvPr id="57" name="Rounded Rectangle 56"/>
+          <p:cNvPr id="59" name="Rounded Rectangle 58"/>
           <p:cNvSpPr/>
           <p:nvPr/>
         </p:nvSpPr>
@@ -8602,7 +8746,7 @@
       </p:sp>
       <p:sp>
         <p:nvSpPr>
-          <p:cNvPr id="58" name="TextBox 57"/>
+          <p:cNvPr id="60" name="TextBox 59"/>
           <p:cNvSpPr txBox="1"/>
           <p:nvPr/>
         </p:nvSpPr>
@@ -8667,17 +8811,9 @@
           <a:prstGeom prst="rect">
             <a:avLst/>
           </a:prstGeom>
-          <a:gradFill rotWithShape="1">
-            <a:gsLst>
-              <a:gs pos="0">
-                <a:srgbClr val="0B1B2B"/>
-              </a:gs>
-              <a:gs pos="100000">
-                <a:srgbClr val="183B5C"/>
-              </a:gs>
-            </a:gsLst>
-            <a:lin scaled="0" ang="0"/>
-          </a:gradFill>
+          <a:solidFill>
+            <a:srgbClr val="0B1B2B"/>
+          </a:solidFill>
           <a:ln>
             <a:noFill/>
           </a:ln>
@@ -8708,6 +8844,94 @@
       <p:sp>
         <p:nvSpPr>
           <p:cNvPr id="3" name="Rectangle 2"/>
+          <p:cNvSpPr/>
+          <p:nvPr/>
+        </p:nvSpPr>
+        <p:spPr>
+          <a:xfrm>
+            <a:off x="7498079" y="0"/>
+            <a:ext cx="4693616" cy="1481328"/>
+          </a:xfrm>
+          <a:prstGeom prst="rect">
+            <a:avLst/>
+          </a:prstGeom>
+          <a:solidFill>
+            <a:srgbClr val="183B5C"/>
+          </a:solidFill>
+          <a:ln>
+            <a:noFill/>
+          </a:ln>
+          <a:effectLst/>
+        </p:spPr>
+        <p:style>
+          <a:lnRef idx="1">
+            <a:schemeClr val="accent1"/>
+          </a:lnRef>
+          <a:fillRef idx="3">
+            <a:schemeClr val="accent1"/>
+          </a:fillRef>
+          <a:effectRef idx="2">
+            <a:schemeClr val="accent1"/>
+          </a:effectRef>
+          <a:fontRef idx="minor">
+            <a:schemeClr val="lt1"/>
+          </a:fontRef>
+        </p:style>
+        <p:txBody>
+          <a:bodyPr rtlCol="0" anchor="ctr" wrap="square"/>
+          <a:lstStyle/>
+          <a:p>
+            <a:pPr algn="ctr"/>
+          </a:p>
+        </p:txBody>
+      </p:sp>
+      <p:sp>
+        <p:nvSpPr>
+          <p:cNvPr id="4" name="Rectangle 3"/>
+          <p:cNvSpPr/>
+          <p:nvPr/>
+        </p:nvSpPr>
+        <p:spPr>
+          <a:xfrm>
+            <a:off x="7040880" y="0"/>
+            <a:ext cx="457200" cy="1481328"/>
+          </a:xfrm>
+          <a:prstGeom prst="rect">
+            <a:avLst/>
+          </a:prstGeom>
+          <a:solidFill>
+            <a:srgbClr val="112B44"/>
+          </a:solidFill>
+          <a:ln>
+            <a:noFill/>
+          </a:ln>
+          <a:effectLst/>
+        </p:spPr>
+        <p:style>
+          <a:lnRef idx="1">
+            <a:schemeClr val="accent1"/>
+          </a:lnRef>
+          <a:fillRef idx="3">
+            <a:schemeClr val="accent1"/>
+          </a:fillRef>
+          <a:effectRef idx="2">
+            <a:schemeClr val="accent1"/>
+          </a:effectRef>
+          <a:fontRef idx="minor">
+            <a:schemeClr val="lt1"/>
+          </a:fontRef>
+        </p:style>
+        <p:txBody>
+          <a:bodyPr rtlCol="0" anchor="ctr" wrap="square"/>
+          <a:lstStyle/>
+          <a:p>
+            <a:pPr algn="ctr"/>
+          </a:p>
+        </p:txBody>
+      </p:sp>
+      <p:sp>
+        <p:nvSpPr>
+          <p:cNvPr id="5" name="Rectangle 4"/>
           <p:cNvSpPr/>
           <p:nvPr/>
         </p:nvSpPr>
@@ -8751,7 +8975,7 @@
       </p:sp>
       <p:sp>
         <p:nvSpPr>
-          <p:cNvPr id="4" name="TextBox 3"/>
+          <p:cNvPr id="6" name="TextBox 5"/>
           <p:cNvSpPr txBox="1"/>
           <p:nvPr/>
         </p:nvSpPr>
@@ -8786,7 +9010,7 @@
       </p:sp>
       <p:sp>
         <p:nvSpPr>
-          <p:cNvPr id="5" name="TextBox 4"/>
+          <p:cNvPr id="7" name="TextBox 6"/>
           <p:cNvSpPr txBox="1"/>
           <p:nvPr/>
         </p:nvSpPr>
@@ -8821,7 +9045,7 @@
       </p:sp>
       <p:sp>
         <p:nvSpPr>
-          <p:cNvPr id="6" name="Oval 5"/>
+          <p:cNvPr id="8" name="Oval 7"/>
           <p:cNvSpPr/>
           <p:nvPr/>
         </p:nvSpPr>
@@ -8867,7 +9091,7 @@
       </p:sp>
       <p:sp>
         <p:nvSpPr>
-          <p:cNvPr id="7" name="TextBox 6"/>
+          <p:cNvPr id="9" name="TextBox 8"/>
           <p:cNvSpPr txBox="1"/>
           <p:nvPr/>
         </p:nvSpPr>
@@ -8902,7 +9126,7 @@
       </p:sp>
       <p:sp>
         <p:nvSpPr>
-          <p:cNvPr id="8" name="TextBox 7"/>
+          <p:cNvPr id="10" name="TextBox 9"/>
           <p:cNvSpPr txBox="1"/>
           <p:nvPr/>
         </p:nvSpPr>
@@ -8937,7 +9161,7 @@
       </p:sp>
       <p:sp>
         <p:nvSpPr>
-          <p:cNvPr id="9" name="Oval 8"/>
+          <p:cNvPr id="11" name="Oval 10"/>
           <p:cNvSpPr/>
           <p:nvPr/>
         </p:nvSpPr>
@@ -8983,7 +9207,7 @@
       </p:sp>
       <p:sp>
         <p:nvSpPr>
-          <p:cNvPr id="10" name="TextBox 9"/>
+          <p:cNvPr id="12" name="TextBox 11"/>
           <p:cNvSpPr txBox="1"/>
           <p:nvPr/>
         </p:nvSpPr>
@@ -9018,7 +9242,7 @@
       </p:sp>
       <p:sp>
         <p:nvSpPr>
-          <p:cNvPr id="11" name="TextBox 10"/>
+          <p:cNvPr id="13" name="TextBox 12"/>
           <p:cNvSpPr txBox="1"/>
           <p:nvPr/>
         </p:nvSpPr>
@@ -9053,7 +9277,7 @@
       </p:sp>
       <p:sp>
         <p:nvSpPr>
-          <p:cNvPr id="12" name="Oval 11"/>
+          <p:cNvPr id="14" name="Oval 13"/>
           <p:cNvSpPr/>
           <p:nvPr/>
         </p:nvSpPr>
@@ -9099,7 +9323,7 @@
       </p:sp>
       <p:sp>
         <p:nvSpPr>
-          <p:cNvPr id="13" name="TextBox 12"/>
+          <p:cNvPr id="15" name="TextBox 14"/>
           <p:cNvSpPr txBox="1"/>
           <p:nvPr/>
         </p:nvSpPr>
@@ -9134,7 +9358,7 @@
       </p:sp>
       <p:sp>
         <p:nvSpPr>
-          <p:cNvPr id="14" name="TextBox 13"/>
+          <p:cNvPr id="16" name="TextBox 15"/>
           <p:cNvSpPr txBox="1"/>
           <p:nvPr/>
         </p:nvSpPr>
@@ -9169,7 +9393,7 @@
       </p:sp>
       <p:sp>
         <p:nvSpPr>
-          <p:cNvPr id="15" name="TextBox 14"/>
+          <p:cNvPr id="17" name="TextBox 16"/>
           <p:cNvSpPr txBox="1"/>
           <p:nvPr/>
         </p:nvSpPr>
@@ -9204,7 +9428,7 @@
       </p:sp>
       <p:sp>
         <p:nvSpPr>
-          <p:cNvPr id="16" name="Oval 15"/>
+          <p:cNvPr id="18" name="Oval 17"/>
           <p:cNvSpPr/>
           <p:nvPr/>
         </p:nvSpPr>
@@ -9250,7 +9474,7 @@
       </p:sp>
       <p:sp>
         <p:nvSpPr>
-          <p:cNvPr id="17" name="Oval 16"/>
+          <p:cNvPr id="19" name="Oval 18"/>
           <p:cNvSpPr/>
           <p:nvPr/>
         </p:nvSpPr>
@@ -9296,7 +9520,7 @@
       </p:sp>
       <p:sp>
         <p:nvSpPr>
-          <p:cNvPr id="18" name="Oval 17"/>
+          <p:cNvPr id="20" name="Oval 19"/>
           <p:cNvSpPr/>
           <p:nvPr/>
         </p:nvSpPr>
@@ -9342,7 +9566,7 @@
       </p:sp>
       <p:sp>
         <p:nvSpPr>
-          <p:cNvPr id="19" name="TextBox 18"/>
+          <p:cNvPr id="21" name="TextBox 20"/>
           <p:cNvSpPr txBox="1"/>
           <p:nvPr/>
         </p:nvSpPr>
@@ -9389,7 +9613,7 @@
       </p:sp>
       <p:sp>
         <p:nvSpPr>
-          <p:cNvPr id="20" name="TextBox 19"/>
+          <p:cNvPr id="22" name="TextBox 21"/>
           <p:cNvSpPr txBox="1"/>
           <p:nvPr/>
         </p:nvSpPr>
@@ -9424,7 +9648,7 @@
       </p:sp>
       <p:sp>
         <p:nvSpPr>
-          <p:cNvPr id="21" name="TextBox 20"/>
+          <p:cNvPr id="23" name="TextBox 22"/>
           <p:cNvSpPr txBox="1"/>
           <p:nvPr/>
         </p:nvSpPr>
@@ -9459,7 +9683,7 @@
       </p:sp>
       <p:sp>
         <p:nvSpPr>
-          <p:cNvPr id="22" name="Oval 21"/>
+          <p:cNvPr id="24" name="Oval 23"/>
           <p:cNvSpPr/>
           <p:nvPr/>
         </p:nvSpPr>
@@ -9505,7 +9729,7 @@
       </p:sp>
       <p:sp>
         <p:nvSpPr>
-          <p:cNvPr id="23" name="Oval 22"/>
+          <p:cNvPr id="25" name="Oval 24"/>
           <p:cNvSpPr/>
           <p:nvPr/>
         </p:nvSpPr>
@@ -9551,7 +9775,7 @@
       </p:sp>
       <p:sp>
         <p:nvSpPr>
-          <p:cNvPr id="24" name="Oval 23"/>
+          <p:cNvPr id="26" name="Oval 25"/>
           <p:cNvSpPr/>
           <p:nvPr/>
         </p:nvSpPr>
@@ -9597,7 +9821,7 @@
       </p:sp>
       <p:sp>
         <p:nvSpPr>
-          <p:cNvPr id="25" name="Oval 24"/>
+          <p:cNvPr id="27" name="Oval 26"/>
           <p:cNvSpPr/>
           <p:nvPr/>
         </p:nvSpPr>
@@ -9643,7 +9867,7 @@
       </p:sp>
       <p:sp>
         <p:nvSpPr>
-          <p:cNvPr id="26" name="Oval 25"/>
+          <p:cNvPr id="28" name="Oval 27"/>
           <p:cNvSpPr/>
           <p:nvPr/>
         </p:nvSpPr>
@@ -9689,7 +9913,7 @@
       </p:sp>
       <p:sp>
         <p:nvSpPr>
-          <p:cNvPr id="27" name="Oval 26"/>
+          <p:cNvPr id="29" name="Oval 28"/>
           <p:cNvSpPr/>
           <p:nvPr/>
         </p:nvSpPr>
@@ -9735,7 +9959,7 @@
       </p:sp>
       <p:sp>
         <p:nvSpPr>
-          <p:cNvPr id="28" name="Oval 27"/>
+          <p:cNvPr id="30" name="Oval 29"/>
           <p:cNvSpPr/>
           <p:nvPr/>
         </p:nvSpPr>
@@ -9781,7 +10005,7 @@
       </p:sp>
       <p:sp>
         <p:nvSpPr>
-          <p:cNvPr id="29" name="Oval 28"/>
+          <p:cNvPr id="31" name="Oval 30"/>
           <p:cNvSpPr/>
           <p:nvPr/>
         </p:nvSpPr>
@@ -9827,7 +10051,7 @@
       </p:sp>
       <p:sp>
         <p:nvSpPr>
-          <p:cNvPr id="30" name="Oval 29"/>
+          <p:cNvPr id="32" name="Oval 31"/>
           <p:cNvSpPr/>
           <p:nvPr/>
         </p:nvSpPr>
@@ -9873,7 +10097,7 @@
       </p:sp>
       <p:sp>
         <p:nvSpPr>
-          <p:cNvPr id="31" name="Oval 30"/>
+          <p:cNvPr id="33" name="Oval 32"/>
           <p:cNvSpPr/>
           <p:nvPr/>
         </p:nvSpPr>
@@ -9919,7 +10143,7 @@
       </p:sp>
       <p:sp>
         <p:nvSpPr>
-          <p:cNvPr id="32" name="Oval 31"/>
+          <p:cNvPr id="34" name="Oval 33"/>
           <p:cNvSpPr/>
           <p:nvPr/>
         </p:nvSpPr>
@@ -9965,7 +10189,7 @@
       </p:sp>
       <p:sp>
         <p:nvSpPr>
-          <p:cNvPr id="33" name="Oval 32"/>
+          <p:cNvPr id="35" name="Oval 34"/>
           <p:cNvSpPr/>
           <p:nvPr/>
         </p:nvSpPr>
@@ -10011,7 +10235,7 @@
       </p:sp>
       <p:sp>
         <p:nvSpPr>
-          <p:cNvPr id="34" name="Rounded Rectangle 33"/>
+          <p:cNvPr id="36" name="Rounded Rectangle 35"/>
           <p:cNvSpPr/>
           <p:nvPr/>
         </p:nvSpPr>
@@ -10059,7 +10283,7 @@
       </p:sp>
       <p:sp>
         <p:nvSpPr>
-          <p:cNvPr id="35" name="TextBox 34"/>
+          <p:cNvPr id="37" name="TextBox 36"/>
           <p:cNvSpPr txBox="1"/>
           <p:nvPr/>
         </p:nvSpPr>
@@ -10094,7 +10318,7 @@
       </p:sp>
       <p:sp>
         <p:nvSpPr>
-          <p:cNvPr id="36" name="TextBox 35"/>
+          <p:cNvPr id="38" name="TextBox 37"/>
           <p:cNvSpPr txBox="1"/>
           <p:nvPr/>
         </p:nvSpPr>
@@ -10129,7 +10353,7 @@
       </p:sp>
       <p:sp>
         <p:nvSpPr>
-          <p:cNvPr id="37" name="Rectangle 36"/>
+          <p:cNvPr id="39" name="Rectangle 38"/>
           <p:cNvSpPr/>
           <p:nvPr/>
         </p:nvSpPr>
@@ -10173,7 +10397,7 @@
       </p:sp>
       <p:sp>
         <p:nvSpPr>
-          <p:cNvPr id="38" name="TextBox 37"/>
+          <p:cNvPr id="40" name="TextBox 39"/>
           <p:cNvSpPr txBox="1"/>
           <p:nvPr/>
         </p:nvSpPr>
@@ -10208,7 +10432,7 @@
       </p:sp>
       <p:sp>
         <p:nvSpPr>
-          <p:cNvPr id="39" name="Oval 38"/>
+          <p:cNvPr id="41" name="Oval 40"/>
           <p:cNvSpPr/>
           <p:nvPr/>
         </p:nvSpPr>
@@ -10252,7 +10476,7 @@
       </p:sp>
       <p:sp>
         <p:nvSpPr>
-          <p:cNvPr id="40" name="TextBox 39"/>
+          <p:cNvPr id="42" name="TextBox 41"/>
           <p:cNvSpPr txBox="1"/>
           <p:nvPr/>
         </p:nvSpPr>
@@ -10287,7 +10511,7 @@
       </p:sp>
       <p:sp>
         <p:nvSpPr>
-          <p:cNvPr id="41" name="TextBox 40"/>
+          <p:cNvPr id="43" name="TextBox 42"/>
           <p:cNvSpPr txBox="1"/>
           <p:nvPr/>
         </p:nvSpPr>
@@ -10331,7 +10555,7 @@
       </p:sp>
       <p:sp>
         <p:nvSpPr>
-          <p:cNvPr id="42" name="Oval 41"/>
+          <p:cNvPr id="44" name="Oval 43"/>
           <p:cNvSpPr/>
           <p:nvPr/>
         </p:nvSpPr>
@@ -10375,7 +10599,7 @@
       </p:sp>
       <p:sp>
         <p:nvSpPr>
-          <p:cNvPr id="43" name="TextBox 42"/>
+          <p:cNvPr id="45" name="TextBox 44"/>
           <p:cNvSpPr txBox="1"/>
           <p:nvPr/>
         </p:nvSpPr>
@@ -10410,7 +10634,7 @@
       </p:sp>
       <p:sp>
         <p:nvSpPr>
-          <p:cNvPr id="44" name="TextBox 43"/>
+          <p:cNvPr id="46" name="TextBox 45"/>
           <p:cNvSpPr txBox="1"/>
           <p:nvPr/>
         </p:nvSpPr>
@@ -10454,7 +10678,7 @@
       </p:sp>
       <p:sp>
         <p:nvSpPr>
-          <p:cNvPr id="45" name="Oval 44"/>
+          <p:cNvPr id="47" name="Oval 46"/>
           <p:cNvSpPr/>
           <p:nvPr/>
         </p:nvSpPr>
@@ -10498,7 +10722,7 @@
       </p:sp>
       <p:sp>
         <p:nvSpPr>
-          <p:cNvPr id="46" name="TextBox 45"/>
+          <p:cNvPr id="48" name="TextBox 47"/>
           <p:cNvSpPr txBox="1"/>
           <p:nvPr/>
         </p:nvSpPr>
@@ -10533,7 +10757,7 @@
       </p:sp>
       <p:sp>
         <p:nvSpPr>
-          <p:cNvPr id="47" name="TextBox 46"/>
+          <p:cNvPr id="49" name="TextBox 48"/>
           <p:cNvSpPr txBox="1"/>
           <p:nvPr/>
         </p:nvSpPr>
@@ -10577,7 +10801,7 @@
       </p:sp>
       <p:sp>
         <p:nvSpPr>
-          <p:cNvPr id="48" name="Rectangle 47"/>
+          <p:cNvPr id="50" name="Rectangle 49"/>
           <p:cNvSpPr/>
           <p:nvPr/>
         </p:nvSpPr>
@@ -10621,7 +10845,7 @@
       </p:sp>
       <p:sp>
         <p:nvSpPr>
-          <p:cNvPr id="49" name="TextBox 48"/>
+          <p:cNvPr id="51" name="TextBox 50"/>
           <p:cNvSpPr txBox="1"/>
           <p:nvPr/>
         </p:nvSpPr>
@@ -10656,7 +10880,7 @@
       </p:sp>
       <p:sp>
         <p:nvSpPr>
-          <p:cNvPr id="50" name="Oval 49"/>
+          <p:cNvPr id="52" name="Oval 51"/>
           <p:cNvSpPr/>
           <p:nvPr/>
         </p:nvSpPr>
@@ -10700,7 +10924,7 @@
       </p:sp>
       <p:sp>
         <p:nvSpPr>
-          <p:cNvPr id="51" name="TextBox 50"/>
+          <p:cNvPr id="53" name="TextBox 52"/>
           <p:cNvSpPr txBox="1"/>
           <p:nvPr/>
         </p:nvSpPr>
@@ -10735,7 +10959,7 @@
       </p:sp>
       <p:sp>
         <p:nvSpPr>
-          <p:cNvPr id="52" name="TextBox 51"/>
+          <p:cNvPr id="54" name="TextBox 53"/>
           <p:cNvSpPr txBox="1"/>
           <p:nvPr/>
         </p:nvSpPr>
@@ -10779,7 +11003,7 @@
       </p:sp>
       <p:sp>
         <p:nvSpPr>
-          <p:cNvPr id="53" name="Oval 52"/>
+          <p:cNvPr id="55" name="Oval 54"/>
           <p:cNvSpPr/>
           <p:nvPr/>
         </p:nvSpPr>
@@ -10823,7 +11047,7 @@
       </p:sp>
       <p:sp>
         <p:nvSpPr>
-          <p:cNvPr id="54" name="TextBox 53"/>
+          <p:cNvPr id="56" name="TextBox 55"/>
           <p:cNvSpPr txBox="1"/>
           <p:nvPr/>
         </p:nvSpPr>
@@ -10858,7 +11082,7 @@
       </p:sp>
       <p:sp>
         <p:nvSpPr>
-          <p:cNvPr id="55" name="TextBox 54"/>
+          <p:cNvPr id="57" name="TextBox 56"/>
           <p:cNvSpPr txBox="1"/>
           <p:nvPr/>
         </p:nvSpPr>
@@ -10902,7 +11126,7 @@
       </p:sp>
       <p:sp>
         <p:nvSpPr>
-          <p:cNvPr id="56" name="Oval 55"/>
+          <p:cNvPr id="58" name="Oval 57"/>
           <p:cNvSpPr/>
           <p:nvPr/>
         </p:nvSpPr>
@@ -10946,7 +11170,7 @@
       </p:sp>
       <p:sp>
         <p:nvSpPr>
-          <p:cNvPr id="57" name="TextBox 56"/>
+          <p:cNvPr id="59" name="TextBox 58"/>
           <p:cNvSpPr txBox="1"/>
           <p:nvPr/>
         </p:nvSpPr>
@@ -10981,7 +11205,7 @@
       </p:sp>
       <p:sp>
         <p:nvSpPr>
-          <p:cNvPr id="58" name="TextBox 57"/>
+          <p:cNvPr id="60" name="TextBox 59"/>
           <p:cNvSpPr txBox="1"/>
           <p:nvPr/>
         </p:nvSpPr>
@@ -11025,7 +11249,7 @@
       </p:sp>
       <p:sp>
         <p:nvSpPr>
-          <p:cNvPr id="59" name="Rectangle 58"/>
+          <p:cNvPr id="61" name="Rectangle 60"/>
           <p:cNvSpPr/>
           <p:nvPr/>
         </p:nvSpPr>
@@ -11069,7 +11293,7 @@
       </p:sp>
       <p:sp>
         <p:nvSpPr>
-          <p:cNvPr id="60" name="TextBox 59"/>
+          <p:cNvPr id="62" name="TextBox 61"/>
           <p:cNvSpPr txBox="1"/>
           <p:nvPr/>
         </p:nvSpPr>
@@ -11104,7 +11328,7 @@
       </p:sp>
       <p:sp>
         <p:nvSpPr>
-          <p:cNvPr id="61" name="Oval 60"/>
+          <p:cNvPr id="63" name="Oval 62"/>
           <p:cNvSpPr/>
           <p:nvPr/>
         </p:nvSpPr>
@@ -11148,7 +11372,7 @@
       </p:sp>
       <p:sp>
         <p:nvSpPr>
-          <p:cNvPr id="62" name="TextBox 61"/>
+          <p:cNvPr id="64" name="TextBox 63"/>
           <p:cNvSpPr txBox="1"/>
           <p:nvPr/>
         </p:nvSpPr>
@@ -11183,7 +11407,7 @@
       </p:sp>
       <p:sp>
         <p:nvSpPr>
-          <p:cNvPr id="63" name="TextBox 62"/>
+          <p:cNvPr id="65" name="TextBox 64"/>
           <p:cNvSpPr txBox="1"/>
           <p:nvPr/>
         </p:nvSpPr>
@@ -11227,7 +11451,7 @@
       </p:sp>
       <p:sp>
         <p:nvSpPr>
-          <p:cNvPr id="64" name="Oval 63"/>
+          <p:cNvPr id="66" name="Oval 65"/>
           <p:cNvSpPr/>
           <p:nvPr/>
         </p:nvSpPr>
@@ -11271,7 +11495,7 @@
       </p:sp>
       <p:sp>
         <p:nvSpPr>
-          <p:cNvPr id="65" name="TextBox 64"/>
+          <p:cNvPr id="67" name="TextBox 66"/>
           <p:cNvSpPr txBox="1"/>
           <p:nvPr/>
         </p:nvSpPr>
@@ -11306,7 +11530,7 @@
       </p:sp>
       <p:sp>
         <p:nvSpPr>
-          <p:cNvPr id="66" name="TextBox 65"/>
+          <p:cNvPr id="68" name="TextBox 67"/>
           <p:cNvSpPr txBox="1"/>
           <p:nvPr/>
         </p:nvSpPr>
@@ -11350,7 +11574,7 @@
       </p:sp>
       <p:sp>
         <p:nvSpPr>
-          <p:cNvPr id="67" name="Oval 66"/>
+          <p:cNvPr id="69" name="Oval 68"/>
           <p:cNvSpPr/>
           <p:nvPr/>
         </p:nvSpPr>
@@ -11394,7 +11618,7 @@
       </p:sp>
       <p:sp>
         <p:nvSpPr>
-          <p:cNvPr id="68" name="TextBox 67"/>
+          <p:cNvPr id="70" name="TextBox 69"/>
           <p:cNvSpPr txBox="1"/>
           <p:nvPr/>
         </p:nvSpPr>
@@ -11429,7 +11653,7 @@
       </p:sp>
       <p:sp>
         <p:nvSpPr>
-          <p:cNvPr id="69" name="TextBox 68"/>
+          <p:cNvPr id="71" name="TextBox 70"/>
           <p:cNvSpPr txBox="1"/>
           <p:nvPr/>
         </p:nvSpPr>
@@ -11473,7 +11697,7 @@
       </p:sp>
       <p:sp>
         <p:nvSpPr>
-          <p:cNvPr id="70" name="TextBox 69"/>
+          <p:cNvPr id="72" name="TextBox 71"/>
           <p:cNvSpPr txBox="1"/>
           <p:nvPr/>
         </p:nvSpPr>
@@ -11508,7 +11732,7 @@
       </p:sp>
       <p:cxnSp>
         <p:nvCxnSpPr>
-          <p:cNvPr id="71" name="Connector 70"/>
+          <p:cNvPr id="73" name="Connector 72"/>
           <p:cNvCxnSpPr/>
           <p:nvPr/>
         </p:nvCxnSpPr>
@@ -11543,7 +11767,7 @@
       </p:cxnSp>
       <p:sp>
         <p:nvSpPr>
-          <p:cNvPr id="72" name="Oval 71"/>
+          <p:cNvPr id="74" name="Oval 73"/>
           <p:cNvSpPr/>
           <p:nvPr/>
         </p:nvSpPr>
@@ -11587,7 +11811,7 @@
       </p:sp>
       <p:sp>
         <p:nvSpPr>
-          <p:cNvPr id="73" name="TextBox 72"/>
+          <p:cNvPr id="75" name="TextBox 74"/>
           <p:cNvSpPr txBox="1"/>
           <p:nvPr/>
         </p:nvSpPr>
@@ -11622,7 +11846,7 @@
       </p:sp>
       <p:sp>
         <p:nvSpPr>
-          <p:cNvPr id="74" name="TextBox 73"/>
+          <p:cNvPr id="76" name="TextBox 75"/>
           <p:cNvSpPr txBox="1"/>
           <p:nvPr/>
         </p:nvSpPr>
@@ -11657,7 +11881,7 @@
       </p:sp>
       <p:sp>
         <p:nvSpPr>
-          <p:cNvPr id="75" name="Oval 74"/>
+          <p:cNvPr id="77" name="Oval 76"/>
           <p:cNvSpPr/>
           <p:nvPr/>
         </p:nvSpPr>
@@ -11701,7 +11925,7 @@
       </p:sp>
       <p:sp>
         <p:nvSpPr>
-          <p:cNvPr id="76" name="TextBox 75"/>
+          <p:cNvPr id="78" name="TextBox 77"/>
           <p:cNvSpPr txBox="1"/>
           <p:nvPr/>
         </p:nvSpPr>
@@ -11736,7 +11960,7 @@
       </p:sp>
       <p:sp>
         <p:nvSpPr>
-          <p:cNvPr id="77" name="TextBox 76"/>
+          <p:cNvPr id="79" name="TextBox 78"/>
           <p:cNvSpPr txBox="1"/>
           <p:nvPr/>
         </p:nvSpPr>
@@ -11771,7 +11995,7 @@
       </p:sp>
       <p:sp>
         <p:nvSpPr>
-          <p:cNvPr id="78" name="Oval 77"/>
+          <p:cNvPr id="80" name="Oval 79"/>
           <p:cNvSpPr/>
           <p:nvPr/>
         </p:nvSpPr>
@@ -11815,7 +12039,7 @@
       </p:sp>
       <p:sp>
         <p:nvSpPr>
-          <p:cNvPr id="79" name="TextBox 78"/>
+          <p:cNvPr id="81" name="TextBox 80"/>
           <p:cNvSpPr txBox="1"/>
           <p:nvPr/>
         </p:nvSpPr>
@@ -11850,7 +12074,7 @@
       </p:sp>
       <p:sp>
         <p:nvSpPr>
-          <p:cNvPr id="80" name="TextBox 79"/>
+          <p:cNvPr id="82" name="TextBox 81"/>
           <p:cNvSpPr txBox="1"/>
           <p:nvPr/>
         </p:nvSpPr>

</xml_diff>